<commit_message>
FMDS Riscos: inclui CTH-000022830 e CTH-000031305 (dono Rodrigo Coji Kimati)
Os dois controles são da coordenação Serra Sul; no Bwise ainda estão na
hierarquia EFC e no nome da antiga dona. Painel com 29 controles.

Co-Authored-By: Claude Opus 5.5 <noreply@anthropic.com>
</commit_message>
<xml_diff>
--- a/plataforma-integridade/projects/fmds-riscos/FMDS_Serra_Sul_2026-09-30.pptx
+++ b/plataforma-integridade/projects/fmds-riscos/FMDS_Serra_Sul_2026-09-30.pptx
@@ -240,7 +240,7 @@
                   <c:v>5</c:v>
                 </c:pt>
                 <c:pt idx="4">
-                  <c:v>3</c:v>
+                  <c:v>5</c:v>
                 </c:pt>
                 <c:pt idx="5">
                   <c:v>2</c:v>
@@ -9875,7 +9875,7 @@
                           <a:ea typeface="Segoe UI" pitchFamily="34" charset="-122"/>
                           <a:cs typeface="Segoe UI" pitchFamily="34" charset="-120"/>
                         </a:rPr>
-                        <a:t>25 de 27</a:t>
+                        <a:t>27 de 29</a:t>
                       </a:r>
                       <a:endParaRPr lang="en-US" sz="1200" dirty="0">
                         <a:latin typeface="Segoe UI" charset="0"/>
@@ -10127,7 +10127,7 @@
                           <a:ea typeface="Segoe UI" pitchFamily="34" charset="-122"/>
                           <a:cs typeface="Segoe UI" pitchFamily="34" charset="-120"/>
                         </a:rPr>
-                        <a:t>112</a:t>
+                        <a:t>118</a:t>
                       </a:r>
                       <a:endParaRPr lang="en-US" sz="1200" dirty="0">
                         <a:latin typeface="Segoe UI" charset="0"/>
@@ -10177,7 +10177,7 @@
                           <a:ea typeface="Segoe UI" pitchFamily="34" charset="-122"/>
                           <a:cs typeface="Segoe UI" pitchFamily="34" charset="-120"/>
                         </a:rPr>
-                        <a:t>ativos estruturais · Mina 55 · Usina 57</a:t>
+                        <a:t>ativos estruturais · Mina 55 · Usina 63</a:t>
                       </a:r>
                       <a:endParaRPr lang="en-US" sz="1200" dirty="0">
                         <a:latin typeface="Segoe UI" charset="0"/>
@@ -11640,7 +11640,7 @@
                           <a:ea typeface="Segoe UI" pitchFamily="34" charset="-122"/>
                           <a:cs typeface="Segoe UI" pitchFamily="34" charset="-120"/>
                         </a:rPr>
-                        <a:t>25</a:t>
+                        <a:t>27</a:t>
                       </a:r>
                       <a:endParaRPr lang="en-US" sz="1100" dirty="0">
                         <a:latin typeface="Segoe UI" charset="0"/>
@@ -11690,7 +11690,7 @@
                           <a:ea typeface="Segoe UI" pitchFamily="34" charset="-122"/>
                           <a:cs typeface="Segoe UI" pitchFamily="34" charset="-120"/>
                         </a:rPr>
-                        <a:t>25</a:t>
+                        <a:t>27</a:t>
                       </a:r>
                       <a:endParaRPr lang="en-US" sz="1100" dirty="0">
                         <a:latin typeface="Segoe UI" charset="0"/>
@@ -12196,7 +12196,7 @@
                           <a:ea typeface="Segoe UI" pitchFamily="34" charset="-122"/>
                           <a:cs typeface="Segoe UI" pitchFamily="34" charset="-120"/>
                         </a:rPr>
-                        <a:t>Divergências SAP × Bwise</a:t>
+                        <a:t>Ativos estruturais</a:t>
                       </a:r>
                       <a:endParaRPr lang="en-US" sz="1100" dirty="0">
                         <a:latin typeface="Segoe UI" charset="0"/>
@@ -12246,7 +12246,7 @@
                           <a:ea typeface="Segoe UI" pitchFamily="34" charset="-122"/>
                           <a:cs typeface="Segoe UI" pitchFamily="34" charset="-120"/>
                         </a:rPr>
-                        <a:t>2</a:t>
+                        <a:t>116</a:t>
                       </a:r>
                       <a:endParaRPr lang="en-US" sz="1100" dirty="0">
                         <a:latin typeface="Segoe UI" charset="0"/>
@@ -12296,7 +12296,7 @@
                           <a:ea typeface="Segoe UI" pitchFamily="34" charset="-122"/>
                           <a:cs typeface="Segoe UI" pitchFamily="34" charset="-120"/>
                         </a:rPr>
-                        <a:t>3</a:t>
+                        <a:t>118</a:t>
                       </a:r>
                       <a:endParaRPr lang="en-US" sz="1100" dirty="0">
                         <a:latin typeface="Segoe UI" charset="0"/>
@@ -12340,13 +12340,13 @@
                       <a:r>
                         <a:rPr lang="en-US" sz="1100" b="1" dirty="0">
                           <a:solidFill>
-                            <a:srgbClr val="B42318"/>
+                            <a:srgbClr val="475467"/>
                           </a:solidFill>
                           <a:latin typeface="Segoe UI" pitchFamily="34" charset="0"/>
                           <a:ea typeface="Segoe UI" pitchFamily="34" charset="-122"/>
                           <a:cs typeface="Segoe UI" pitchFamily="34" charset="-120"/>
                         </a:rPr>
-                        <a:t>▲ 1</a:t>
+                        <a:t>▲ 2</a:t>
                       </a:r>
                       <a:endParaRPr lang="en-US" sz="1100" dirty="0">
                         <a:latin typeface="Segoe UI" charset="0"/>
@@ -14411,7 +14411,7 @@
                 <a:ea typeface="Segoe UI" pitchFamily="34" charset="-122"/>
                 <a:cs typeface="Segoe UI" pitchFamily="34" charset="-120"/>
               </a:rPr>
-              <a:t>25/27</a:t>
+              <a:t>27/29</a:t>
             </a:r>
             <a:endParaRPr lang="en-US" sz="3200" dirty="0"/>
           </a:p>
@@ -16470,7 +16470,7 @@
                 <a:ea typeface="Segoe UI" pitchFamily="34" charset="-122"/>
                 <a:cs typeface="Segoe UI" pitchFamily="34" charset="-120"/>
               </a:rPr>
-              <a:t>112 ativos estruturais sob 23 controles; 3 divergem do Bwise</a:t>
+              <a:t>118 ativos estruturais sob 25 controles; 3 divergem do Bwise</a:t>
             </a:r>
             <a:endParaRPr lang="en-US" sz="2400" dirty="0"/>
           </a:p>
@@ -16548,7 +16548,7 @@
                 <a:ea typeface="Segoe UI" pitchFamily="34" charset="-122"/>
                 <a:cs typeface="Segoe UI" pitchFamily="34" charset="-120"/>
               </a:rPr>
-              <a:t>112</a:t>
+              <a:t>118</a:t>
             </a:r>
             <a:endParaRPr lang="en-US" sz="4800" dirty="0"/>
           </a:p>
@@ -16587,7 +16587,7 @@
                 <a:ea typeface="Segoe UI" pitchFamily="34" charset="-122"/>
                 <a:cs typeface="Segoe UI" pitchFamily="34" charset="-120"/>
               </a:rPr>
-              <a:t>ativos estruturais em 105 locais de instalação</a:t>
+              <a:t>ativos estruturais em 109 locais de instalação</a:t>
             </a:r>
             <a:endParaRPr lang="en-US" sz="1100" dirty="0"/>
           </a:p>
@@ -16602,7 +16602,7 @@
         <p:spPr>
           <a:xfrm>
             <a:off x="548640" y="2743200"/>
-            <a:ext cx="1678904" cy="182880"/>
+            <a:ext cx="1592141" cy="182880"/>
           </a:xfrm>
           <a:prstGeom prst="rect">
             <a:avLst/>
@@ -16621,8 +16621,8 @@
         </p:nvSpPr>
         <p:spPr>
           <a:xfrm>
-            <a:off x="2254976" y="2743200"/>
-            <a:ext cx="1768384" cy="182880"/>
+            <a:off x="2168213" y="2743200"/>
+            <a:ext cx="1855147" cy="182880"/>
           </a:xfrm>
           <a:prstGeom prst="rect">
             <a:avLst/>
@@ -16759,7 +16759,7 @@
                 <a:ea typeface="Segoe UI" pitchFamily="34" charset="-122"/>
                 <a:cs typeface="Segoe UI" pitchFamily="34" charset="-120"/>
               </a:rPr>
-              <a:t>57  </a:t>
+              <a:t>63  </a:t>
             </a:r>
             <a:pPr indent="0" marL="0">
               <a:buNone/>
@@ -23926,7 +23926,7 @@
                 <a:ea typeface="Segoe UI" pitchFamily="34" charset="-122"/>
                 <a:cs typeface="Segoe UI" pitchFamily="34" charset="-120"/>
               </a:rPr>
-              <a:t>103 equipamentos com ativos críticos · 16 com notas P1 · 43 sem notas ativas. Lista completa na tela Equipamentos do painel.</a:t>
+              <a:t>106 equipamentos com ativos críticos · 16 com notas P1 · 46 sem notas ativas. Lista completa na tela Equipamentos do painel.</a:t>
             </a:r>
             <a:endParaRPr lang="en-US" sz="1100" dirty="0"/>
           </a:p>

</xml_diff>